<commit_message>
Reorganise repo structure and Ignore Microsoft Office temporary files
</commit_message>
<xml_diff>
--- a/DemoPoster.pptx
+++ b/DemoPoster.pptx
@@ -107,6 +107,11 @@
       </a:defRPr>
     </a:lvl9pPr>
   </p:defaultTextStyle>
+  <p:extLst>
+    <p:ext uri="{EFAFB233-063F-42B5-8137-9DF3F51BA10A}">
+      <p15:sldGuideLst xmlns:p15="http://schemas.microsoft.com/office/powerpoint/2012/main"/>
+    </p:ext>
+  </p:extLst>
 </p:presentation>
 </file>
 
@@ -192,7 +197,7 @@
           <a:p>
             <a:fld id="{293FEB80-F6E0-4EF5-BD51-8512E838742F}" type="datetimeFigureOut">
               <a:rPr lang="en-AU" smtClean="0"/>
-              <a:t>3/09/2026</a:t>
+              <a:t>5/09/2026</a:t>
             </a:fld>
             <a:endParaRPr lang="en-AU"/>
           </a:p>
@@ -609,7 +614,7 @@
           <a:p>
             <a:fld id="{CDB4428F-B80D-4182-AF79-E5EB56282A5B}" type="datetimeFigureOut">
               <a:rPr lang="en-AU" smtClean="0"/>
-              <a:t>3/09/2026</a:t>
+              <a:t>5/09/2026</a:t>
             </a:fld>
             <a:endParaRPr lang="en-AU"/>
           </a:p>
@@ -809,7 +814,7 @@
           <a:p>
             <a:fld id="{CDB4428F-B80D-4182-AF79-E5EB56282A5B}" type="datetimeFigureOut">
               <a:rPr lang="en-AU" smtClean="0"/>
-              <a:t>3/09/2026</a:t>
+              <a:t>5/09/2026</a:t>
             </a:fld>
             <a:endParaRPr lang="en-AU"/>
           </a:p>
@@ -1019,7 +1024,7 @@
           <a:p>
             <a:fld id="{CDB4428F-B80D-4182-AF79-E5EB56282A5B}" type="datetimeFigureOut">
               <a:rPr lang="en-AU" smtClean="0"/>
-              <a:t>3/09/2026</a:t>
+              <a:t>5/09/2026</a:t>
             </a:fld>
             <a:endParaRPr lang="en-AU"/>
           </a:p>
@@ -1442,7 +1447,7 @@
           <a:p>
             <a:fld id="{CDB4428F-B80D-4182-AF79-E5EB56282A5B}" type="datetimeFigureOut">
               <a:rPr lang="en-AU" smtClean="0"/>
-              <a:t>3/09/2026</a:t>
+              <a:t>5/09/2026</a:t>
             </a:fld>
             <a:endParaRPr lang="en-AU"/>
           </a:p>
@@ -1718,7 +1723,7 @@
           <a:p>
             <a:fld id="{CDB4428F-B80D-4182-AF79-E5EB56282A5B}" type="datetimeFigureOut">
               <a:rPr lang="en-AU" smtClean="0"/>
-              <a:t>3/09/2026</a:t>
+              <a:t>5/09/2026</a:t>
             </a:fld>
             <a:endParaRPr lang="en-AU"/>
           </a:p>
@@ -1986,7 +1991,7 @@
           <a:p>
             <a:fld id="{CDB4428F-B80D-4182-AF79-E5EB56282A5B}" type="datetimeFigureOut">
               <a:rPr lang="en-AU" smtClean="0"/>
-              <a:t>3/09/2026</a:t>
+              <a:t>5/09/2026</a:t>
             </a:fld>
             <a:endParaRPr lang="en-AU"/>
           </a:p>
@@ -2401,7 +2406,7 @@
           <a:p>
             <a:fld id="{CDB4428F-B80D-4182-AF79-E5EB56282A5B}" type="datetimeFigureOut">
               <a:rPr lang="en-AU" smtClean="0"/>
-              <a:t>3/09/2026</a:t>
+              <a:t>5/09/2026</a:t>
             </a:fld>
             <a:endParaRPr lang="en-AU"/>
           </a:p>
@@ -2543,7 +2548,7 @@
           <a:p>
             <a:fld id="{CDB4428F-B80D-4182-AF79-E5EB56282A5B}" type="datetimeFigureOut">
               <a:rPr lang="en-AU" smtClean="0"/>
-              <a:t>3/09/2026</a:t>
+              <a:t>5/09/2026</a:t>
             </a:fld>
             <a:endParaRPr lang="en-AU"/>
           </a:p>
@@ -2656,7 +2661,7 @@
           <a:p>
             <a:fld id="{CDB4428F-B80D-4182-AF79-E5EB56282A5B}" type="datetimeFigureOut">
               <a:rPr lang="en-AU" smtClean="0"/>
-              <a:t>3/09/2026</a:t>
+              <a:t>5/09/2026</a:t>
             </a:fld>
             <a:endParaRPr lang="en-AU"/>
           </a:p>
@@ -2969,7 +2974,7 @@
           <a:p>
             <a:fld id="{CDB4428F-B80D-4182-AF79-E5EB56282A5B}" type="datetimeFigureOut">
               <a:rPr lang="en-AU" smtClean="0"/>
-              <a:t>3/09/2026</a:t>
+              <a:t>5/09/2026</a:t>
             </a:fld>
             <a:endParaRPr lang="en-AU"/>
           </a:p>
@@ -3258,7 +3263,7 @@
           <a:p>
             <a:fld id="{CDB4428F-B80D-4182-AF79-E5EB56282A5B}" type="datetimeFigureOut">
               <a:rPr lang="en-AU" smtClean="0"/>
-              <a:t>3/09/2026</a:t>
+              <a:t>5/09/2026</a:t>
             </a:fld>
             <a:endParaRPr lang="en-AU"/>
           </a:p>
@@ -3501,7 +3506,7 @@
           <a:p>
             <a:fld id="{CDB4428F-B80D-4182-AF79-E5EB56282A5B}" type="datetimeFigureOut">
               <a:rPr lang="en-AU" smtClean="0"/>
-              <a:t>3/09/2026</a:t>
+              <a:t>5/09/2026</a:t>
             </a:fld>
             <a:endParaRPr lang="en-AU"/>
           </a:p>
@@ -3937,33 +3942,35 @@
         </p:nvSpPr>
         <p:spPr>
           <a:xfrm>
-            <a:off x="6838181" y="72001"/>
-            <a:ext cx="5353819" cy="4910400"/>
+            <a:off x="7231930" y="2870463"/>
+            <a:ext cx="2662581" cy="1767567"/>
           </a:xfrm>
+          <a:solidFill>
+            <a:schemeClr val="bg1"/>
+          </a:solidFill>
         </p:spPr>
         <p:txBody>
-          <a:bodyPr/>
-          <a:lstStyle/>
-          <a:p>
-            <a:pPr algn="ctr"/>
-            <a:r>
-              <a:rPr lang="en-AU" sz="3200" dirty="0"/>
+          <a:bodyPr lIns="198000" tIns="126000" bIns="90000"/>
+          <a:lstStyle/>
+          <a:p>
+            <a:r>
+              <a:rPr lang="en-AU" sz="2800" dirty="0"/>
               <a:t>Checkout the </a:t>
             </a:r>
             <a:r>
-              <a:rPr lang="en-AU" sz="3200" b="1" dirty="0"/>
+              <a:rPr lang="en-AU" sz="2800" b="1" dirty="0"/>
               <a:t>Interactive</a:t>
             </a:r>
             <a:r>
-              <a:rPr lang="en-AU" sz="3200" dirty="0"/>
+              <a:rPr lang="en-AU" sz="2800" dirty="0"/>
               <a:t>  </a:t>
             </a:r>
             <a:r>
-              <a:rPr lang="en-AU" sz="3200" b="1" dirty="0"/>
+              <a:rPr lang="en-AU" sz="2800" b="1" dirty="0"/>
               <a:t>Digital Twin </a:t>
             </a:r>
             <a:r>
-              <a:rPr lang="en-AU" sz="3200" dirty="0"/>
+              <a:rPr lang="en-AU" sz="2800" dirty="0"/>
               <a:t>via this QR Code!</a:t>
             </a:r>
           </a:p>
@@ -3983,8 +3990,8 @@
         </p:nvSpPr>
         <p:spPr>
           <a:xfrm>
-            <a:off x="6462309" y="4602950"/>
-            <a:ext cx="6109200" cy="276999"/>
+            <a:off x="7374190" y="4638030"/>
+            <a:ext cx="4183159" cy="261610"/>
           </a:xfrm>
           <a:prstGeom prst="rect">
             <a:avLst/>
@@ -4007,7 +4014,7 @@
               <a:buNone/>
             </a:pPr>
             <a:r>
-              <a:rPr lang="en-AU" sz="1200" b="0" i="0" dirty="0">
+              <a:rPr lang="en-AU" sz="1100" b="0" i="0" dirty="0">
                 <a:solidFill>
                   <a:schemeClr val="tx1"/>
                 </a:solidFill>
@@ -4047,38 +4054,8 @@
         </p:blipFill>
         <p:spPr>
           <a:xfrm>
-            <a:off x="7757959" y="1085050"/>
-            <a:ext cx="3517900" cy="3517900"/>
-          </a:xfrm>
-          <a:prstGeom prst="rect">
-            <a:avLst/>
-          </a:prstGeom>
-        </p:spPr>
-      </p:pic>
-      <p:pic>
-        <p:nvPicPr>
-          <p:cNvPr id="10" name="Picture 9">
-            <a:extLst>
-              <a:ext uri="{FF2B5EF4-FFF2-40B4-BE49-F238E27FC236}">
-                <a16:creationId xmlns:a16="http://schemas.microsoft.com/office/drawing/2014/main" id="{D1DABB30-730C-2B8E-0EBC-788203AE1816}"/>
-              </a:ext>
-            </a:extLst>
-          </p:cNvPr>
-          <p:cNvPicPr>
-            <a:picLocks noChangeAspect="1"/>
-          </p:cNvPicPr>
-          <p:nvPr/>
-        </p:nvPicPr>
-        <p:blipFill>
-          <a:blip r:embed="rId3"/>
-          <a:stretch>
-            <a:fillRect/>
-          </a:stretch>
-        </p:blipFill>
-        <p:spPr>
-          <a:xfrm>
-            <a:off x="509664" y="1420437"/>
-            <a:ext cx="5586336" cy="4550528"/>
+            <a:off x="9894511" y="2870463"/>
+            <a:ext cx="1767567" cy="1767567"/>
           </a:xfrm>
           <a:prstGeom prst="rect">
             <a:avLst/>
@@ -4139,6 +4116,147 @@
           </a:p>
         </p:txBody>
       </p:sp>
+      <p:pic>
+        <p:nvPicPr>
+          <p:cNvPr id="5" name="Camera 4">
+            <a:extLst>
+              <a:ext uri="{FF2B5EF4-FFF2-40B4-BE49-F238E27FC236}">
+                <a16:creationId xmlns:a16="http://schemas.microsoft.com/office/drawing/2014/main" id="{67DDB5AE-8397-F245-2FFF-9E6436B209EE}"/>
+              </a:ext>
+            </a:extLst>
+          </p:cNvPr>
+          <p:cNvPicPr>
+            <a:picLocks noChangeAspect="1"/>
+            <a:extLst>
+              <a:ext uri="{51228E76-BA90-4043-B771-695A4F85340A}">
+                <alf:liveFeedProps xmlns:alf="http://schemas.microsoft.com/office/drawing/2021/livefeed"/>
+              </a:ext>
+            </a:extLst>
+          </p:cNvPicPr>
+          <p:nvPr/>
+        </p:nvPicPr>
+        <p:blipFill>
+          <a:blip>
+            <a:extLst>
+              <a:ext uri="{96DAC541-7B7A-43D3-8B79-37D633B846F1}">
+                <asvg:svgBlip xmlns:asvg="http://schemas.microsoft.com/office/drawing/2016/SVG/main" r:embed="rId3"/>
+              </a:ext>
+            </a:extLst>
+          </a:blip>
+          <a:stretch>
+            <a:fillRect/>
+          </a:stretch>
+        </p:blipFill>
+        <p:spPr>
+          <a:xfrm>
+            <a:off x="529922" y="1223229"/>
+            <a:ext cx="5552878" cy="5289171"/>
+          </a:xfrm>
+          <a:prstGeom prst="rect">
+            <a:avLst/>
+          </a:prstGeom>
+          <a:ln>
+            <a:noFill/>
+          </a:ln>
+          <a:effectLst/>
+        </p:spPr>
+      </p:pic>
+      <p:pic>
+        <p:nvPicPr>
+          <p:cNvPr id="11" name="Picture 10">
+            <a:extLst>
+              <a:ext uri="{FF2B5EF4-FFF2-40B4-BE49-F238E27FC236}">
+                <a16:creationId xmlns:a16="http://schemas.microsoft.com/office/drawing/2014/main" id="{CF41B6D5-C92A-59C8-42A7-C2F555C8D436}"/>
+              </a:ext>
+            </a:extLst>
+          </p:cNvPr>
+          <p:cNvPicPr>
+            <a:picLocks noChangeAspect="1"/>
+          </p:cNvPicPr>
+          <p:nvPr/>
+        </p:nvPicPr>
+        <p:blipFill>
+          <a:blip r:embed="rId4"/>
+          <a:stretch>
+            <a:fillRect/>
+          </a:stretch>
+        </p:blipFill>
+        <p:spPr>
+          <a:xfrm>
+            <a:off x="7046685" y="345599"/>
+            <a:ext cx="4838171" cy="2341811"/>
+          </a:xfrm>
+          <a:prstGeom prst="rect">
+            <a:avLst/>
+          </a:prstGeom>
+        </p:spPr>
+      </p:pic>
+      <mc:AlternateContent xmlns:mc="http://schemas.openxmlformats.org/markup-compatibility/2006">
+        <mc:Choice xmlns:we="http://schemas.microsoft.com/office/webextensions/webextension/2010/11" xmlns:pca="http://schemas.microsoft.com/office/powerpoint/2013/contentapp" Requires="we pca">
+          <p:graphicFrame>
+            <p:nvGraphicFramePr>
+              <p:cNvPr id="7" name="Add-in 6" title="Web Viewer 2.0">
+                <a:extLst>
+                  <a:ext uri="{FF2B5EF4-FFF2-40B4-BE49-F238E27FC236}">
+                    <a16:creationId xmlns:a16="http://schemas.microsoft.com/office/drawing/2014/main" id="{7B229C74-B4E8-DA01-5DE2-362464479F6F}"/>
+                  </a:ext>
+                </a:extLst>
+              </p:cNvPr>
+              <p:cNvGraphicFramePr>
+                <a:graphicFrameLocks noGrp="1"/>
+              </p:cNvGraphicFramePr>
+              <p:nvPr>
+                <p:extLst>
+                  <p:ext uri="{D42A27DB-BD31-4B8C-83A1-F6EECF244321}">
+                    <p14:modId xmlns:p14="http://schemas.microsoft.com/office/powerpoint/2010/main" val="1786549975"/>
+                  </p:ext>
+                </p:extLst>
+              </p:nvPr>
+            </p:nvGraphicFramePr>
+            <p:xfrm>
+              <a:off x="7046685" y="350589"/>
+              <a:ext cx="4838171" cy="2341811"/>
+            </p:xfrm>
+            <a:graphic>
+              <a:graphicData uri="http://schemas.microsoft.com/office/webextensions/webextension/2010/11">
+                <we:webextensionref xmlns:we="http://schemas.microsoft.com/office/webextensions/webextension/2010/11" xmlns:r="http://schemas.openxmlformats.org/officeDocument/2006/relationships" r:id="rId5"/>
+              </a:graphicData>
+            </a:graphic>
+          </p:graphicFrame>
+        </mc:Choice>
+        <mc:Fallback>
+          <p:pic>
+            <p:nvPicPr>
+              <p:cNvPr id="7" name="Add-in 6" title="Web Viewer 2.0">
+                <a:extLst>
+                  <a:ext uri="{FF2B5EF4-FFF2-40B4-BE49-F238E27FC236}">
+                    <a16:creationId xmlns:a16="http://schemas.microsoft.com/office/drawing/2014/main" id="{7B229C74-B4E8-DA01-5DE2-362464479F6F}"/>
+                  </a:ext>
+                </a:extLst>
+              </p:cNvPr>
+              <p:cNvPicPr>
+                <a:picLocks noGrp="1" noRot="1" noChangeAspect="1" noMove="1" noResize="1" noEditPoints="1" noAdjustHandles="1" noChangeArrowheads="1" noChangeShapeType="1"/>
+              </p:cNvPicPr>
+              <p:nvPr/>
+            </p:nvPicPr>
+            <p:blipFill>
+              <a:blip r:embed="rId6"/>
+              <a:stretch>
+                <a:fillRect/>
+              </a:stretch>
+            </p:blipFill>
+            <p:spPr>
+              <a:xfrm>
+                <a:off x="7046685" y="350589"/>
+                <a:ext cx="4838171" cy="2341811"/>
+              </a:xfrm>
+              <a:prstGeom prst="rect">
+                <a:avLst/>
+              </a:prstGeom>
+            </p:spPr>
+          </p:pic>
+        </mc:Fallback>
+      </mc:AlternateContent>
     </p:spTree>
     <p:extLst>
       <p:ext uri="{BB962C8B-B14F-4D97-AF65-F5344CB8AC3E}">
@@ -4780,4 +4898,19 @@
     </a:ext>
   </a:extLst>
 </a:theme>
+</file>
+
+<file path=ppt/webextensions/webextension1.xml><?xml version="1.0" encoding="utf-8"?>
+<we:webextension xmlns:we="http://schemas.microsoft.com/office/webextensions/webextension/2010/11" id="{23138744-470F-45DD-95C7-C40F4ABDED53}">
+  <we:reference id="wa200010526" version="1.1.0.0" store="en-US" storeType="OMEX"/>
+  <we:alternateReferences>
+    <we:reference id="wa200010526" version="1.1.0.0" store="wa200010526" storeType="OMEX"/>
+  </we:alternateReferences>
+  <we:properties>
+    <we:property name="webViewerUrl" value="&quot;https://randomrunt.github.io/UNSWMicromouseDemo/#chapter-meet&quot;"/>
+    <we:property name="webViewerViewportMode" value="&quot;desktop&quot;"/>
+  </we:properties>
+  <we:bindings/>
+  <we:snapshot xmlns:r="http://schemas.openxmlformats.org/officeDocument/2006/relationships" r:embed="rId1"/>
+</we:webextension>
 </file>
</xml_diff>